<commit_message>
Revise eight classes for twelve learners and publish reading copies
</commit_message>
<xml_diff>
--- a/03_Presentations/00_Mentor_Workshop.pptx
+++ b/03_Presentations/00_Mentor_Workshop.pptx
@@ -2,20 +2,20 @@
 <file path=ppt/presentation.xml><?xml version="1.0" encoding="utf-8"?>
 <p:presentation xmlns:p="http://schemas.openxmlformats.org/presentationml/2006/main">
   <p:sldMasterIdLst>
-    <p:sldMasterId xmlns:r="http://schemas.openxmlformats.org/officeDocument/2006/relationships" id="2147483648" r:id="R6a2617732a904b02"/>
+    <p:sldMasterId xmlns:r="http://schemas.openxmlformats.org/officeDocument/2006/relationships" id="2147483648" r:id="R3aa87b5fc47c4124"/>
   </p:sldMasterIdLst>
   <p:notesMasterIdLst>
-    <p:notesMasterId xmlns:r="http://schemas.openxmlformats.org/officeDocument/2006/relationships" r:id="R847f53063caa4197"/>
+    <p:notesMasterId xmlns:r="http://schemas.openxmlformats.org/officeDocument/2006/relationships" r:id="Rff4efce33db149b4"/>
   </p:notesMasterIdLst>
   <p:sldIdLst>
-    <p:sldId xmlns:r="http://schemas.openxmlformats.org/officeDocument/2006/relationships" id="256" r:id="Rbfe9c7d1420c4e8d"/>
-    <p:sldId xmlns:r="http://schemas.openxmlformats.org/officeDocument/2006/relationships" id="257" r:id="R642d7e1005bd4d80"/>
-    <p:sldId xmlns:r="http://schemas.openxmlformats.org/officeDocument/2006/relationships" id="258" r:id="Re6616e2490964c24"/>
-    <p:sldId xmlns:r="http://schemas.openxmlformats.org/officeDocument/2006/relationships" id="259" r:id="R5b0c5784a7894730"/>
-    <p:sldId xmlns:r="http://schemas.openxmlformats.org/officeDocument/2006/relationships" id="260" r:id="R29ddbf4031a341de"/>
-    <p:sldId xmlns:r="http://schemas.openxmlformats.org/officeDocument/2006/relationships" id="261" r:id="R968245873c3e49ab"/>
-    <p:sldId xmlns:r="http://schemas.openxmlformats.org/officeDocument/2006/relationships" id="262" r:id="R2198d4f8cb414d53"/>
-    <p:sldId xmlns:r="http://schemas.openxmlformats.org/officeDocument/2006/relationships" id="263" r:id="R185070ccd54f4895"/>
+    <p:sldId xmlns:r="http://schemas.openxmlformats.org/officeDocument/2006/relationships" id="256" r:id="R36401529ca9a4ef3"/>
+    <p:sldId xmlns:r="http://schemas.openxmlformats.org/officeDocument/2006/relationships" id="257" r:id="R27ba0413337c4b5e"/>
+    <p:sldId xmlns:r="http://schemas.openxmlformats.org/officeDocument/2006/relationships" id="258" r:id="R86d18e1118e24037"/>
+    <p:sldId xmlns:r="http://schemas.openxmlformats.org/officeDocument/2006/relationships" id="259" r:id="Red5d15f3c5c743fd"/>
+    <p:sldId xmlns:r="http://schemas.openxmlformats.org/officeDocument/2006/relationships" id="260" r:id="R9638cb31faaf415a"/>
+    <p:sldId xmlns:r="http://schemas.openxmlformats.org/officeDocument/2006/relationships" id="261" r:id="R8d80176334ba419e"/>
+    <p:sldId xmlns:r="http://schemas.openxmlformats.org/officeDocument/2006/relationships" id="262" r:id="R85c99e4f48e14f77"/>
+    <p:sldId xmlns:r="http://schemas.openxmlformats.org/officeDocument/2006/relationships" id="263" r:id="R80cc79d39637457f"/>
   </p:sldIdLst>
   <p:sldSz cx="12192000" cy="6858000"/>
   <p:notesSz cx="6858000" cy="9144000"/>
@@ -449,7 +449,7 @@
           <a:lstStyle xmlns:a="http://schemas.openxmlformats.org/drawingml/2006/main"/>
           <a:p xmlns:a="http://schemas.openxmlformats.org/drawingml/2006/main">
             <a:r>
-              <a:t>0–10 minutes: discuss why the YMCA program exists and what a beginner should experience. The educator keeps responsibility for supervision and local procedures. Ask each mentor to name a time someone helped them learn without taking over.</a:t>
+              <a:t>This general 120-minute workshop deck is a reference. For the student-led build-first preparation session use 01_Instructor/Trainer_Session_Plan.md and Trainer_Work_Orders.md. Instructors practiced October 25; actual kit acceptance records remain to be supplied.</a:t>
             </a:r>
           </a:p>
         </p:txBody>
@@ -519,7 +519,7 @@
           <a:lstStyle xmlns:a="http://schemas.openxmlformats.org/drawingml/2006/main"/>
           <a:p xmlns:a="http://schemas.openxmlformats.org/drawingml/2006/main">
             <a:r>
-              <a:t>10–30 minutes: assemble and inspect the official base, trace physical cables, and run 00_mentor_smoke_test.py with wheels raised, then in a clear lane. This curriculum port map overrides the original build wiring. Label the robot front. Demonstrate the actual app and hub stop controls. Build PDF: https://assets.education.lego.com/v3/assets/blt293eea581807678a/blt06873e1b438a0d7e/5ec8e66f033ad5045f4c79a6/driving-base-bi-pdf-book1of1.pdf?locale=en-us</a:t>
+              <a:t>[object Object]</a:t>
             </a:r>
           </a:p>
         </p:txBody>
@@ -589,7 +589,7 @@
           <a:lstStyle xmlns:a="http://schemas.openxmlformats.org/drawingml/2006/main"/>
           <a:p xmlns:a="http://schemas.openxmlformats.org/drawingml/2006/main">
             <a:r>
-              <a:t>30–50 minutes: mentors practice weeks 1–3. The recipe function in the actual file is called student_recipe. Explain wheel degrees, variables, and counted loops. Have every mentor predict before running. Use current SPIKE App 3 modules, not Legacy or Pybricks examples. App help: https://spike.legoeducation.com/prime/modal/help/lls-help-python</a:t>
+              <a:t>[object Object]</a:t>
             </a:r>
           </a:p>
         </p:txBody>
@@ -659,7 +659,7 @@
           <a:lstStyle xmlns:a="http://schemas.openxmlformats.org/drawingml/2006/main"/>
           <a:p xmlns:a="http://schemas.openxmlformats.org/drawingml/2006/main">
             <a:r>
-              <a:t>50–70 minutes: use 00_sensor_readings.py while stationary. Compare readings with a ruler and with bright/dark surfaces. Run bounded movement only after the readings make sense. Source for distance units and invalid reading check: https://education.lego.com/en-au/lessons/spike-python-u3-sensor-control/spike-python-u3l3/. The helper code also checks after the final permitted movement.</a:t>
+              <a:t>[object Object]</a:t>
             </a:r>
           </a:p>
         </p:txBody>
@@ -729,7 +729,7 @@
           <a:lstStyle xmlns:a="http://schemas.openxmlformats.org/drawingml/2006/main"/>
           <a:p xmlns:a="http://schemas.openxmlformats.org/drawingml/2006/main">
             <a:r>
-              <a:t>70–85 minutes: build a flat bumper or U-shaped guide using spare pieces from the base kit. Geometry depends on the actual pieces, so the educator must prepare and photograph a working mount. The comparison should change one feature. Preserve both pairs’ components.</a:t>
+              <a:t>Practice the weekly build-table routine. Prepare four team parts packs and two mentor examples. A team can build with a footprint/mounting template while another uses the robot. Check every approved attachment with the actual stopped base before testing. Teach builder, designer/parts manager and tester/reporter jobs.</a:t>
             </a:r>
           </a:p>
         </p:txBody>
@@ -799,7 +799,7 @@
           <a:lstStyle xmlns:a="http://schemas.openxmlformats.org/drawingml/2006/main"/>
           <a:p xmlns:a="http://schemas.openxmlformats.org/drawingml/2006/main">
             <a:r>
-              <a:t>85–100 minutes: each mentor teaches a five-minute mini lesson to another mentor. Ask a question, give a little thinking time, offer one hint, and return control. Check that the mentor invites both students to explain. Avoid correcting the whole project while students watch.</a:t>
+              <a:t>[object Object]</a:t>
             </a:r>
           </a:p>
         </p:txBody>
@@ -869,7 +869,7 @@
           <a:lstStyle xmlns:a="http://schemas.openxmlformats.org/drawingml/2006/main"/>
           <a:p xmlns:a="http://schemas.openxmlformats.org/drawingml/2006/main">
             <a:r>
-              <a:t>100–110 minutes: rehearse transitions and a keyboard-takeover scenario. With two laptops, devices stay at kit stations and planning uses paper. A pair gets about 17 minutes of direct robot time; each child gets a share of those minutes. Week 8 uses a different showcase schedule.</a:t>
+              <a:t>Driver edits and starts after clear. Navigator predicts, positions the stopped robot/payload and checks the lane. Observer measures and records a brief result. At the build table, rotate builder, designer/parts manager and tester/reporter. Switch roles at minutes 18, 22, 30, 34, 40, 42, 46 and 48. Two laptops stay with robots; two show build references without hub connections. Four mentors cover the four stations; additional mentors float.</a:t>
             </a:r>
           </a:p>
         </p:txBody>
@@ -939,7 +939,7 @@
           <a:lstStyle xmlns:a="http://schemas.openxmlformats.org/drawingml/2006/main"/>
           <a:p xmlns:a="http://schemas.openxmlformats.org/drawingml/2006/main">
             <a:r>
-              <a:t>110–120 minutes: complete the mentor readiness check. Review YMCA procedures and who to ask for help. Evidence records use student IDs. Take photos or quotes only through the agreed permissions. The instructor guide includes a hardware acceptance record that must be completed on both kits.</a:t>
+              <a:t>[object Object]</a:t>
             </a:r>
           </a:p>
         </p:txBody>
@@ -1007,7 +1007,7 @@
   </p:cSld>
   <p:clrMap bg1="lt1" tx1="dk1" bg2="lt2" tx2="dk2" accent1="accent1" accent2="accent2" accent3="accent3" accent4="accent4" accent5="accent5" accent6="accent6" hlink="hlink" folHlink="folHlink"/>
   <p:sldLayoutIdLst>
-    <p:sldLayoutId xmlns:r="http://schemas.openxmlformats.org/officeDocument/2006/relationships" id="2147483649" r:id="Rd580d2130c594808"/>
+    <p:sldLayoutId xmlns:r="http://schemas.openxmlformats.org/officeDocument/2006/relationships" id="2147483649" r:id="R2a3e146a170a40a6"/>
   </p:sldLayoutIdLst>
   <p:txStyles>
     <p:titleStyle>
@@ -1587,6 +1587,7 @@
           <a:lstStyle xmlns:a="http://schemas.openxmlformats.org/drawingml/2006/main"/>
           <a:p xmlns:a="http://schemas.openxmlformats.org/drawingml/2006/main">
             <a:pPr>
+              <a:buNone/>
               <a:defRPr sz="5100" b="1">
                 <a:solidFill>
                   <a:srgbClr val="FFFFFF"/>
@@ -1644,6 +1645,7 @@
           <a:lstStyle xmlns:a="http://schemas.openxmlformats.org/drawingml/2006/main"/>
           <a:p xmlns:a="http://schemas.openxmlformats.org/drawingml/2006/main">
             <a:pPr>
+              <a:buNone/>
               <a:defRPr sz="2475" b="0">
                 <a:solidFill>
                   <a:srgbClr val="9DDADD"/>
@@ -1701,6 +1703,7 @@
           <a:lstStyle xmlns:a="http://schemas.openxmlformats.org/drawingml/2006/main"/>
           <a:p xmlns:a="http://schemas.openxmlformats.org/drawingml/2006/main">
             <a:pPr>
+              <a:buNone/>
               <a:defRPr sz="1425" b="0">
                 <a:solidFill>
                   <a:srgbClr val="B9D4DC"/>
@@ -1787,6 +1790,7 @@
           <a:lstStyle xmlns:a="http://schemas.openxmlformats.org/drawingml/2006/main"/>
           <a:p xmlns:a="http://schemas.openxmlformats.org/drawingml/2006/main">
             <a:pPr>
+              <a:buNone/>
               <a:defRPr sz="3600" b="1">
                 <a:solidFill>
                   <a:srgbClr val="173044"/>
@@ -1844,6 +1848,7 @@
           <a:lstStyle xmlns:a="http://schemas.openxmlformats.org/drawingml/2006/main"/>
           <a:p xmlns:a="http://schemas.openxmlformats.org/drawingml/2006/main">
             <a:pPr>
+              <a:buNone/>
               <a:defRPr sz="2325" b="0">
                 <a:solidFill>
                   <a:srgbClr val="173044"/>
@@ -1901,6 +1906,7 @@
           <a:lstStyle xmlns:a="http://schemas.openxmlformats.org/drawingml/2006/main"/>
           <a:p xmlns:a="http://schemas.openxmlformats.org/drawingml/2006/main">
             <a:pPr>
+              <a:buNone/>
               <a:defRPr sz="2325" b="0">
                 <a:solidFill>
                   <a:srgbClr val="173044"/>
@@ -1958,6 +1964,7 @@
           <a:lstStyle xmlns:a="http://schemas.openxmlformats.org/drawingml/2006/main"/>
           <a:p xmlns:a="http://schemas.openxmlformats.org/drawingml/2006/main">
             <a:pPr>
+              <a:buNone/>
               <a:defRPr sz="2325" b="0">
                 <a:solidFill>
                   <a:srgbClr val="173044"/>
@@ -2015,6 +2022,7 @@
           <a:lstStyle xmlns:a="http://schemas.openxmlformats.org/drawingml/2006/main"/>
           <a:p xmlns:a="http://schemas.openxmlformats.org/drawingml/2006/main">
             <a:pPr>
+              <a:buNone/>
               <a:defRPr sz="2325" b="0">
                 <a:solidFill>
                   <a:srgbClr val="173044"/>
@@ -2101,6 +2109,7 @@
           <a:lstStyle xmlns:a="http://schemas.openxmlformats.org/drawingml/2006/main"/>
           <a:p xmlns:a="http://schemas.openxmlformats.org/drawingml/2006/main">
             <a:pPr>
+              <a:buNone/>
               <a:defRPr sz="3600" b="1">
                 <a:solidFill>
                   <a:srgbClr val="FFFFFF"/>
@@ -2158,6 +2167,7 @@
           <a:lstStyle xmlns:a="http://schemas.openxmlformats.org/drawingml/2006/main"/>
           <a:p xmlns:a="http://schemas.openxmlformats.org/drawingml/2006/main">
             <a:pPr>
+              <a:buNone/>
               <a:defRPr sz="2850" b="0">
                 <a:solidFill>
                   <a:srgbClr val="FFFFFF"/>
@@ -2181,6 +2191,7 @@
           </a:p>
           <a:p xmlns:a="http://schemas.openxmlformats.org/drawingml/2006/main">
             <a:pPr>
+              <a:buNone/>
               <a:defRPr sz="2850" b="0">
                 <a:solidFill>
                   <a:srgbClr val="FFFFFF"/>
@@ -2204,6 +2215,7 @@
           </a:p>
           <a:p xmlns:a="http://schemas.openxmlformats.org/drawingml/2006/main">
             <a:pPr>
+              <a:buNone/>
               <a:defRPr sz="2850" b="0">
                 <a:solidFill>
                   <a:srgbClr val="FFFFFF"/>
@@ -2261,6 +2273,7 @@
           <a:lstStyle xmlns:a="http://schemas.openxmlformats.org/drawingml/2006/main"/>
           <a:p xmlns:a="http://schemas.openxmlformats.org/drawingml/2006/main">
             <a:pPr>
+              <a:buNone/>
               <a:defRPr sz="2175" b="0">
                 <a:solidFill>
                   <a:srgbClr val="9DDADD"/>
@@ -2347,6 +2360,7 @@
           <a:lstStyle xmlns:a="http://schemas.openxmlformats.org/drawingml/2006/main"/>
           <a:p xmlns:a="http://schemas.openxmlformats.org/drawingml/2006/main">
             <a:pPr>
+              <a:buNone/>
               <a:defRPr sz="3600" b="1">
                 <a:solidFill>
                   <a:srgbClr val="173044"/>
@@ -2404,6 +2418,7 @@
           <a:lstStyle xmlns:a="http://schemas.openxmlformats.org/drawingml/2006/main"/>
           <a:p xmlns:a="http://schemas.openxmlformats.org/drawingml/2006/main">
             <a:pPr>
+              <a:buNone/>
               <a:defRPr sz="2250" b="0">
                 <a:solidFill>
                   <a:srgbClr val="173044"/>
@@ -2461,6 +2476,7 @@
           <a:lstStyle xmlns:a="http://schemas.openxmlformats.org/drawingml/2006/main"/>
           <a:p xmlns:a="http://schemas.openxmlformats.org/drawingml/2006/main">
             <a:pPr>
+              <a:buNone/>
               <a:defRPr sz="2250" b="0">
                 <a:solidFill>
                   <a:srgbClr val="173044"/>
@@ -2518,6 +2534,7 @@
           <a:lstStyle xmlns:a="http://schemas.openxmlformats.org/drawingml/2006/main"/>
           <a:p xmlns:a="http://schemas.openxmlformats.org/drawingml/2006/main">
             <a:pPr>
+              <a:buNone/>
               <a:defRPr sz="2250" b="0">
                 <a:solidFill>
                   <a:srgbClr val="173044"/>
@@ -2575,6 +2592,7 @@
           <a:lstStyle xmlns:a="http://schemas.openxmlformats.org/drawingml/2006/main"/>
           <a:p xmlns:a="http://schemas.openxmlformats.org/drawingml/2006/main">
             <a:pPr>
+              <a:buNone/>
               <a:defRPr sz="2250" b="0">
                 <a:solidFill>
                   <a:srgbClr val="173044"/>
@@ -2661,6 +2679,7 @@
           <a:lstStyle xmlns:a="http://schemas.openxmlformats.org/drawingml/2006/main"/>
           <a:p xmlns:a="http://schemas.openxmlformats.org/drawingml/2006/main">
             <a:pPr>
+              <a:buNone/>
               <a:defRPr sz="3600" b="1">
                 <a:solidFill>
                   <a:srgbClr val="173044"/>
@@ -2718,6 +2737,7 @@
           <a:lstStyle xmlns:a="http://schemas.openxmlformats.org/drawingml/2006/main"/>
           <a:p xmlns:a="http://schemas.openxmlformats.org/drawingml/2006/main">
             <a:pPr>
+              <a:buNone/>
               <a:defRPr sz="2250" b="0">
                 <a:solidFill>
                   <a:srgbClr val="173044"/>
@@ -2736,7 +2756,7 @@
                 <a:ea typeface="Arial"/>
                 <a:cs typeface="Arial"/>
               </a:rPr>
-              <a:t>Sketch a plow that guides a lightweight cube.</a:t>
+              <a:t>Build and hand-test a guide for a lightweight cube.</a:t>
             </a:r>
           </a:p>
         </p:txBody>
@@ -2775,6 +2795,7 @@
           <a:lstStyle xmlns:a="http://schemas.openxmlformats.org/drawingml/2006/main"/>
           <a:p xmlns:a="http://schemas.openxmlformats.org/drawingml/2006/main">
             <a:pPr>
+              <a:buNone/>
               <a:defRPr sz="2250" b="0">
                 <a:solidFill>
                   <a:srgbClr val="173044"/>
@@ -2832,6 +2853,7 @@
           <a:lstStyle xmlns:a="http://schemas.openxmlformats.org/drawingml/2006/main"/>
           <a:p xmlns:a="http://schemas.openxmlformats.org/drawingml/2006/main">
             <a:pPr>
+              <a:buNone/>
               <a:defRPr sz="2250" b="0">
                 <a:solidFill>
                   <a:srgbClr val="173044"/>
@@ -2889,6 +2911,7 @@
           <a:lstStyle xmlns:a="http://schemas.openxmlformats.org/drawingml/2006/main"/>
           <a:p xmlns:a="http://schemas.openxmlformats.org/drawingml/2006/main">
             <a:pPr>
+              <a:buNone/>
               <a:defRPr sz="2250" b="0">
                 <a:solidFill>
                   <a:srgbClr val="173044"/>
@@ -2907,7 +2930,7 @@
                 <a:ea typeface="Arial"/>
                 <a:cs typeface="Arial"/>
               </a:rPr>
-              <a:t>Store each pair’s removable attachment separately.</a:t>
+              <a:t>Store each team’s removable attachment separately.</a:t>
             </a:r>
           </a:p>
         </p:txBody>
@@ -2975,6 +2998,7 @@
           <a:lstStyle xmlns:a="http://schemas.openxmlformats.org/drawingml/2006/main"/>
           <a:p xmlns:a="http://schemas.openxmlformats.org/drawingml/2006/main">
             <a:pPr>
+              <a:buNone/>
               <a:defRPr sz="3600" b="1">
                 <a:solidFill>
                   <a:srgbClr val="173044"/>
@@ -3032,6 +3056,7 @@
           <a:lstStyle xmlns:a="http://schemas.openxmlformats.org/drawingml/2006/main"/>
           <a:p xmlns:a="http://schemas.openxmlformats.org/drawingml/2006/main">
             <a:pPr>
+              <a:buNone/>
               <a:defRPr sz="2850" b="0">
                 <a:solidFill>
                   <a:srgbClr val="173044"/>
@@ -3089,6 +3114,7 @@
           <a:lstStyle xmlns:a="http://schemas.openxmlformats.org/drawingml/2006/main"/>
           <a:p xmlns:a="http://schemas.openxmlformats.org/drawingml/2006/main">
             <a:pPr>
+              <a:buNone/>
               <a:defRPr sz="2850" b="0">
                 <a:solidFill>
                   <a:srgbClr val="173044"/>
@@ -3146,6 +3172,7 @@
           <a:lstStyle xmlns:a="http://schemas.openxmlformats.org/drawingml/2006/main"/>
           <a:p xmlns:a="http://schemas.openxmlformats.org/drawingml/2006/main">
             <a:pPr>
+              <a:buNone/>
               <a:defRPr sz="2850" b="0">
                 <a:solidFill>
                   <a:srgbClr val="173044"/>
@@ -3232,6 +3259,7 @@
           <a:lstStyle xmlns:a="http://schemas.openxmlformats.org/drawingml/2006/main"/>
           <a:p xmlns:a="http://schemas.openxmlformats.org/drawingml/2006/main">
             <a:pPr>
+              <a:buNone/>
               <a:defRPr sz="3600" b="1">
                 <a:solidFill>
                   <a:srgbClr val="173044"/>
@@ -3250,7 +3278,7 @@
                 <a:ea typeface="Arial"/>
                 <a:cs typeface="Arial"/>
               </a:rPr>
-              <a:t>Two pairs share each robot</a:t>
+              <a:t>Two teams of three share each robot</a:t>
             </a:r>
           </a:p>
         </p:txBody>
@@ -3289,6 +3317,7 @@
           <a:lstStyle xmlns:a="http://schemas.openxmlformats.org/drawingml/2006/main"/>
           <a:p xmlns:a="http://schemas.openxmlformats.org/drawingml/2006/main">
             <a:pPr>
+              <a:buNone/>
               <a:defRPr sz="2250" b="0">
                 <a:solidFill>
                   <a:srgbClr val="173044"/>
@@ -3307,7 +3336,7 @@
                 <a:ea typeface="Arial"/>
                 <a:cs typeface="Arial"/>
               </a:rPr>
-              <a:t>15–27 minutes   First pair tests, second pair plans.</a:t>
+              <a:t>14–26 minutes   T1/T3 test. T2/T4 build.</a:t>
             </a:r>
           </a:p>
         </p:txBody>
@@ -3346,6 +3375,7 @@
           <a:lstStyle xmlns:a="http://schemas.openxmlformats.org/drawingml/2006/main"/>
           <a:p xmlns:a="http://schemas.openxmlformats.org/drawingml/2006/main">
             <a:pPr>
+              <a:buNone/>
               <a:defRPr sz="2250" b="0">
                 <a:solidFill>
                   <a:srgbClr val="173044"/>
@@ -3364,7 +3394,7 @@
                 <a:ea typeface="Arial"/>
                 <a:cs typeface="Arial"/>
               </a:rPr>
-              <a:t>27–39 minutes   Pairs switch stations.</a:t>
+              <a:t>26–38 minutes   Teams switch stations.</a:t>
             </a:r>
           </a:p>
         </p:txBody>
@@ -3403,6 +3433,7 @@
           <a:lstStyle xmlns:a="http://schemas.openxmlformats.org/drawingml/2006/main"/>
           <a:p xmlns:a="http://schemas.openxmlformats.org/drawingml/2006/main">
             <a:pPr>
+              <a:buNone/>
               <a:defRPr sz="2250" b="0">
                 <a:solidFill>
                   <a:srgbClr val="173044"/>
@@ -3421,7 +3452,7 @@
                 <a:ea typeface="Arial"/>
                 <a:cs typeface="Arial"/>
               </a:rPr>
-              <a:t>39–49 minutes   Each pair gets a five-minute retest.</a:t>
+              <a:t>38–50 minutes   Each team gets a six-minute retest.</a:t>
             </a:r>
           </a:p>
         </p:txBody>
@@ -3460,6 +3491,7 @@
           <a:lstStyle xmlns:a="http://schemas.openxmlformats.org/drawingml/2006/main"/>
           <a:p xmlns:a="http://schemas.openxmlformats.org/drawingml/2006/main">
             <a:pPr>
+              <a:buNone/>
               <a:defRPr sz="2250" b="0">
                 <a:solidFill>
                   <a:srgbClr val="173044"/>
@@ -3478,7 +3510,7 @@
                 <a:ea typeface="Arial"/>
                 <a:cs typeface="Arial"/>
               </a:rPr>
-              <a:t>Drivers swap midway through every robot turn.</a:t>
+              <a:t>Rotate three jobs in equal thirds of each turn.</a:t>
             </a:r>
           </a:p>
         </p:txBody>
@@ -3546,6 +3578,7 @@
           <a:lstStyle xmlns:a="http://schemas.openxmlformats.org/drawingml/2006/main"/>
           <a:p xmlns:a="http://schemas.openxmlformats.org/drawingml/2006/main">
             <a:pPr>
+              <a:buNone/>
               <a:defRPr sz="3600" b="1">
                 <a:solidFill>
                   <a:srgbClr val="173044"/>
@@ -3603,6 +3636,7 @@
           <a:lstStyle xmlns:a="http://schemas.openxmlformats.org/drawingml/2006/main"/>
           <a:p xmlns:a="http://schemas.openxmlformats.org/drawingml/2006/main">
             <a:pPr>
+              <a:buNone/>
               <a:defRPr sz="2250" b="0">
                 <a:solidFill>
                   <a:srgbClr val="173044"/>
@@ -3660,6 +3694,7 @@
           <a:lstStyle xmlns:a="http://schemas.openxmlformats.org/drawingml/2006/main"/>
           <a:p xmlns:a="http://schemas.openxmlformats.org/drawingml/2006/main">
             <a:pPr>
+              <a:buNone/>
               <a:defRPr sz="2250" b="0">
                 <a:solidFill>
                   <a:srgbClr val="173044"/>
@@ -3717,6 +3752,7 @@
           <a:lstStyle xmlns:a="http://schemas.openxmlformats.org/drawingml/2006/main"/>
           <a:p xmlns:a="http://schemas.openxmlformats.org/drawingml/2006/main">
             <a:pPr>
+              <a:buNone/>
               <a:defRPr sz="2250" b="0">
                 <a:solidFill>
                   <a:srgbClr val="173044"/>
@@ -3735,7 +3771,7 @@
                 <a:ea typeface="Arial"/>
                 <a:cs typeface="Arial"/>
               </a:rPr>
-              <a:t>Give both students meaningful operating turns.</a:t>
+              <a:t>Give all three students meaningful operating turns.</a:t>
             </a:r>
           </a:p>
         </p:txBody>
@@ -3774,6 +3810,7 @@
           <a:lstStyle xmlns:a="http://schemas.openxmlformats.org/drawingml/2006/main"/>
           <a:p xmlns:a="http://schemas.openxmlformats.org/drawingml/2006/main">
             <a:pPr>
+              <a:buNone/>
               <a:defRPr sz="2250" b="0">
                 <a:solidFill>
                   <a:srgbClr val="173044"/>
@@ -3792,7 +3829,7 @@
                 <a:ea typeface="Arial"/>
                 <a:cs typeface="Arial"/>
               </a:rPr>
-              <a:t>Save the pair’s work and record what actually happened.</a:t>
+              <a:t>Save the team’s work and record what actually happened.</a:t>
             </a:r>
           </a:p>
         </p:txBody>

</xml_diff>